<commit_message>
Backup, log retention and vulnerability scanning (risks R14, R10, R13)
- tools/backup.py: lakehouse/ and inbox/kvk/ as one verified archive in
  backups/ (Delta logs archived first, manifest, newest 3 kept); restore
  only into an empty folder. Last step of the monthly maintenance job.
- Retention: confirmed_by in the KVK upload log removed after 365 days,
  file paths shortened to the file name (new reports store the name only);
  Dagster runs older than 180 days deleted with their logs, except runs
  holding an asset's latest result; ticks purged after 90 days.
- Maintenance steps now run one after the other (they could overlap).
- .github/workflows/audit.yml: pip-audit on every pinned package, on pin
  changes and weekly; the Docker image's extra packages moved to
  requirements-docker.txt so they are scanned too.
- Docs, risk register, report (Dutch) and deck updated; 383 tests.

Co-Authored-By: Claude Opus 5.5 <noreply@anthropic.com>
</commit_message>
<xml_diff>
--- a/docs/presentatie.pptx
+++ b/docs/presentatie.pptx
@@ -1577,7 +1577,7 @@
           <a:lstStyle/>
           <a:p>
             <a:r>
-              <a:t>Betrouwbaar: 373 tests, ook in GitHub Actions. Verantwoord: geen persoonsgegevens van verzekerden. En generatieve AI: ik heb Claude als ontwikkelassistent gebruikt; zeven keer bleek iets niet te kloppen, zoals een CI-test die als gedaan was afgevinkt maar nooit had gedraaid. Daarom is alles getest en gemeten. Deze slide kan vervallen bij een korter tijdslot. (~1 min)</a:t>
+              <a:t>Betrouwbaar: 383 tests, ook in GitHub Actions. Verantwoord: geen persoonsgegevens van verzekerden. En generatieve AI: ik heb Claude als ontwikkelassistent gebruikt; zeven keer bleek iets niet te kloppen, zoals een CI-test die als gedaan was afgevinkt maar nooit had gedraaid. Daarom is alles getest en gemeten. Deze slide kan vervallen bij een korter tijdslot. (~1 min)</a:t>
             </a:r>
           </a:p>
         </p:txBody>
@@ -10037,7 +10037,7 @@
                 </a:solidFill>
                 <a:latin typeface="Calibri"/>
               </a:rPr>
-              <a:t>373</a:t>
+              <a:t>383</a:t>
             </a:r>
           </a:p>
         </p:txBody>

</xml_diff>

<commit_message>
Review follow-up: backtest of the risk index, sector-key join, stability band, guide for the teacher
- tools/backtest_risk.py: builds the risk index for 13 earlier quarters
  with gold's own code (final figures only) and checks each verdict against
  the next year: higher/lower held in 440 of 440 cases; the trend doesn't
  predict (rising 44% vs stable 45%). Report, dashboard, demo and slides now
  say a trend is no forecast; 4 tests.
- Gold: business counts joined on the sector key instead of the SBI code
  (aggregates have no code, 56102 has two keys); latent, the real risk
  index is identical; a test fails on the old join. Lineage updated.
- 'Band' described as stability, not certainty, everywhere.
- README: 'Start here (for the teacher)'; docs/qa_practice.md with 18
  practice questions for the Q&A; GenAI incident table: the join bug.
- Report trimmed to keep the room for the reflection; 388 tests.

Co-Authored-By: Claude Opus 5.5 <noreply@anthropic.com>
</commit_message>
<xml_diff>
--- a/docs/presentatie.pptx
+++ b/docs/presentatie.pptx
@@ -1017,7 +1017,7 @@
           <a:lstStyle/>
           <a:p>
             <a:r>
-              <a:t>Conclusie: sector en grootte gaan duidelijk samen met verzuim, en het platform maakt dat herhaalbaar en herleidbaar zonder privacyrisico. Mijn advies: gebruik het naast de eigen cijfers en op groepsniveau, bevestig trends met definitieve cijfers, laat compliance meekijken, en koppel pas na een DPIA. Vragen? (~1 min)</a:t>
+              <a:t>Conclusie: sector en grootte gaan duidelijk samen met verzuim, en het platform maakt dat herhaalbaar en herleidbaar zonder privacyrisico. Mijn advies: gebruik het naast de eigen cijfers en op groepsniveau, lees een trend niet als voorspelling, laat compliance meekijken, en koppel pas na een DPIA. Vragen? (~1 min)</a:t>
             </a:r>
           </a:p>
         </p:txBody>
@@ -1437,7 +1437,7 @@
           <a:lstStyle/>
           <a:p>
             <a:r>
-              <a:t>De enquête laat zien waaróm: in de zorg verzuimen meer mensen, langer, en vaker door het werk, vooral besmetting en emotioneel zwaar werk. Maar 42 van de 65 maten liggen binnen de foutmarge, en het blijft samenhang: de cijfers zeggen niets over één werkgever. Ook het trendsignaal is gevoelig: met alleen definitieve cijfers stijgt een andere sector. (~1,5 min)</a:t>
+              <a:t>De enquête laat zien waaróm: in de zorg verzuimen meer mensen, langer, en vaker door het werk, vooral besmetting en emotioneel zwaar werk. Maar 42 van de 65 maten liggen binnen de foutmarge, en het blijft samenhang: de cijfers zeggen niets over één werkgever. En een terugtoets op de historie laat zien: een oordeel hoger of lager houdt een jaar later stand, maar een trend voorspelt niet; met alleen definitieve cijfers stijgt zelfs een andere sector. (~1,5 min)</a:t>
             </a:r>
           </a:p>
         </p:txBody>
@@ -1577,7 +1577,7 @@
           <a:lstStyle/>
           <a:p>
             <a:r>
-              <a:t>Betrouwbaar: 383 tests, ook in GitHub Actions. Verantwoord: geen persoonsgegevens van verzekerden. En generatieve AI: ik heb Claude als ontwikkelassistent gebruikt; zeven keer bleek iets niet te kloppen, zoals een CI-test die als gedaan was afgevinkt maar nooit had gedraaid. Daarom is alles getest en gemeten. Deze slide kan vervallen bij een korter tijdslot. (~1 min)</a:t>
+              <a:t>Betrouwbaar: 388 tests, ook in GitHub Actions. Verantwoord: geen persoonsgegevens van verzekerden. En generatieve AI: ik heb Claude als ontwikkelassistent gebruikt; acht keer bleek iets niet te kloppen, zoals een CI-test die als gedaan was afgevinkt maar nooit had gedraaid, en een verborgen koppelfout die pas een tweede review vond. Daarom is alles getest en gemeten. Deze slide kan vervallen bij een korter tijdslot. (~1 min)</a:t>
             </a:r>
           </a:p>
         </p:txBody>
@@ -4982,7 +4982,7 @@
                 </a:solidFill>
                 <a:latin typeface="Calibri"/>
               </a:rPr>
-              <a:t>Bevestig trends met definitieve cijfers</a:t>
+              <a:t>Lees een trend niet als voorspelling</a:t>
             </a:r>
           </a:p>
           <a:p>
@@ -10037,7 +10037,7 @@
                 </a:solidFill>
                 <a:latin typeface="Calibri"/>
               </a:rPr>
-              <a:t>383</a:t>
+              <a:t>388</a:t>
             </a:r>
           </a:p>
         </p:txBody>
@@ -10339,7 +10339,7 @@
                 </a:solidFill>
                 <a:latin typeface="Calibri"/>
               </a:rPr>
-              <a:t>7</a:t>
+              <a:t>8</a:t>
             </a:r>
           </a:p>
         </p:txBody>

</xml_diff>

<commit_message>
KVK snapshot date: KVK's own file date instead of the upload day
- checks/kvk.py: reads KVK's export date from the CSV inside the zip
  (file_date); none for a loose CSV or an undated zip (with a warning);
  warns when a start date is later than the file date.
- kvk_agent: file_date in the batch log (schema merge);
  --backfill-file-dates fills old batches from the same file in the inbox.
- Silver: snapshot_date = file date, else the upload day, with
  snapshot_date_source (kvk_file / upload); LOGIC_VERSION 3. Real data:
  2026-10-05 -> 2026-10-01, all other columns identical.
- KVK freshness check uses the file date. Lineage (283 columns), docs,
  report (recommendation done), 395 tests.

Co-Authored-By: Claude Opus 5.5 <noreply@anthropic.com>
</commit_message>
<xml_diff>
--- a/docs/presentatie.pptx
+++ b/docs/presentatie.pptx
@@ -1577,7 +1577,7 @@
           <a:lstStyle/>
           <a:p>
             <a:r>
-              <a:t>Betrouwbaar: 388 tests, ook in GitHub Actions. Verantwoord: geen persoonsgegevens van verzekerden. En generatieve AI: ik heb Claude als ontwikkelassistent gebruikt; acht keer bleek iets niet te kloppen, zoals een CI-test die als gedaan was afgevinkt maar nooit had gedraaid, en een verborgen koppelfout die pas een tweede review vond. Daarom is alles getest en gemeten. Deze slide kan vervallen bij een korter tijdslot. (~1 min)</a:t>
+              <a:t>Betrouwbaar: 395 tests, ook in GitHub Actions. Verantwoord: geen persoonsgegevens van verzekerden. En generatieve AI: ik heb Claude als ontwikkelassistent gebruikt; acht keer bleek iets niet te kloppen, zoals een CI-test die als gedaan was afgevinkt maar nooit had gedraaid, en een verborgen koppelfout die pas een tweede review vond. Daarom is alles getest en gemeten. Deze slide kan vervallen bij een korter tijdslot. (~1 min)</a:t>
             </a:r>
           </a:p>
         </p:txBody>
@@ -10037,7 +10037,7 @@
                 </a:solidFill>
                 <a:latin typeface="Calibri"/>
               </a:rPr>
-              <a:t>388</a:t>
+              <a:t>395</a:t>
             </a:r>
           </a:p>
         </p:txBody>

</xml_diff>

<commit_message>
CategoryGroupID stays text: decided and pinned by a test
An all-empty CBS field gets no null type: delta-rs would write Delta's
'void', which isn't in the Delta protocol (other engines may refuse the
table). Nothing reads the column; raw_json keeps the original. Bronze
README, TODO; 396 tests.

Co-Authored-By: Claude Opus 5.5 <noreply@anthropic.com>
</commit_message>
<xml_diff>
--- a/docs/presentatie.pptx
+++ b/docs/presentatie.pptx
@@ -1577,7 +1577,7 @@
           <a:lstStyle/>
           <a:p>
             <a:r>
-              <a:t>Betrouwbaar: 395 tests, ook in GitHub Actions. Verantwoord: geen persoonsgegevens van verzekerden. En generatieve AI: ik heb Claude als ontwikkelassistent gebruikt; acht keer bleek iets niet te kloppen, zoals een CI-test die als gedaan was afgevinkt maar nooit had gedraaid, en een verborgen koppelfout die pas een tweede review vond. Daarom is alles getest en gemeten. Deze slide kan vervallen bij een korter tijdslot. (~1 min)</a:t>
+              <a:t>Betrouwbaar: 396 tests, ook in GitHub Actions. Verantwoord: geen persoonsgegevens van verzekerden. En generatieve AI: ik heb Claude als ontwikkelassistent gebruikt; acht keer bleek iets niet te kloppen, zoals een CI-test die als gedaan was afgevinkt maar nooit had gedraaid, en een verborgen koppelfout die pas een tweede review vond. Daarom is alles getest en gemeten. Deze slide kan vervallen bij een korter tijdslot. (~1 min)</a:t>
             </a:r>
           </a:p>
         </p:txBody>
@@ -10037,7 +10037,7 @@
                 </a:solidFill>
                 <a:latin typeface="Calibri"/>
               </a:rPr>
-              <a:t>395</a:t>
+              <a:t>396</a:t>
             </a:r>
           </a:p>
         </p:txBody>

</xml_diff>

<commit_message>
Backup: warn on the lakehouse's own disk, refuse with require_other_disk
Backups stay on this disk for now (one disk, no synced folder). Each
backup now logs a warning (also in Dagster) that it is on the same disk;
backup.require_other_disk: true makes it refuse before writing, so an
unplugged USB drive doesn't get its folder on the internal disk.
Instructions, risk register, TODO; 397 tests.

Co-Authored-By: Claude Opus 5.5 <noreply@anthropic.com>
</commit_message>
<xml_diff>
--- a/docs/presentatie.pptx
+++ b/docs/presentatie.pptx
@@ -1577,7 +1577,7 @@
           <a:lstStyle/>
           <a:p>
             <a:r>
-              <a:t>Betrouwbaar: 396 tests, ook in GitHub Actions. Verantwoord: geen persoonsgegevens van verzekerden. En generatieve AI: ik heb Claude als ontwikkelassistent gebruikt; acht keer bleek iets niet te kloppen, zoals een CI-test die als gedaan was afgevinkt maar nooit had gedraaid, en een verborgen koppelfout die pas een tweede review vond. Daarom is alles getest en gemeten. Deze slide kan vervallen bij een korter tijdslot. (~1 min)</a:t>
+              <a:t>Betrouwbaar: 397 tests, ook in GitHub Actions. Verantwoord: geen persoonsgegevens van verzekerden. En generatieve AI: ik heb Claude als ontwikkelassistent gebruikt; acht keer bleek iets niet te kloppen, zoals een CI-test die als gedaan was afgevinkt maar nooit had gedraaid, en een verborgen koppelfout die pas een tweede review vond. Daarom is alles getest en gemeten. Deze slide kan vervallen bij een korter tijdslot. (~1 min)</a:t>
             </a:r>
           </a:p>
         </p:txBody>
@@ -10037,7 +10037,7 @@
                 </a:solidFill>
                 <a:latin typeface="Calibri"/>
               </a:rPr>
-              <a:t>396</a:t>
+              <a:t>397</a:t>
             </a:r>
           </a:p>
         </p:txBody>

</xml_diff>